<commit_message>
Use real brand assets; tidy duplicate files
- Starter deck: woven dark diamond-pattern background (baked from
  pattern-01.png) across all slides; values slide now uses the real
  'Values (Desktop Wallpaper).jpg' full-bleed instead of a card grid.
- Kiosk waiting screen: brand diamond pattern as the field texture.
- install.sh copies pattern-01.png to the kiosk.
- Removed duplicate-named asset copies and the redundant uploads/ folder
  (all were byte-identical to the lowercase assets; originals remain in
  git history). Kept LinkedIn header + pattern-02 as unique brand assets.

Co-Authored-By: Claude Opus 4.8 (1M context) <noreply@anthropic.com>
</commit_message>
<xml_diff>
--- a/starter-deck/board.pptx
+++ b/starter-deck/board.pptx
@@ -3095,12 +3095,20 @@
         <p:nvPr/>
       </p:nvGrpSpPr>
       <p:grpSpPr/>
-      <p:sp>
-        <p:nvSpPr>
-          <p:cNvPr id="2" name="Rectangle 1"/>
-          <p:cNvSpPr/>
-          <p:nvPr/>
-        </p:nvSpPr>
+      <p:pic>
+        <p:nvPicPr>
+          <p:cNvPr id="2" name="Picture 1" descr="_deck_bg.png"/>
+          <p:cNvPicPr>
+            <a:picLocks noChangeAspect="1"/>
+          </p:cNvPicPr>
+          <p:nvPr/>
+        </p:nvPicPr>
+        <p:blipFill>
+          <a:blip r:embed="rId2"/>
+          <a:stretch>
+            <a:fillRect/>
+          </a:stretch>
+        </p:blipFill>
         <p:spPr>
           <a:xfrm>
             <a:off x="0" y="0"/>
@@ -3109,44 +3117,8 @@
           <a:prstGeom prst="rect">
             <a:avLst/>
           </a:prstGeom>
-          <a:gradFill rotWithShape="1">
-            <a:gsLst>
-              <a:gs pos="0">
-                <a:srgbClr val="06120D"/>
-              </a:gs>
-              <a:gs pos="100000">
-                <a:srgbClr val="06120D"/>
-              </a:gs>
-            </a:gsLst>
-            <a:lin scaled="0" ang="16200000"/>
-          </a:gradFill>
-          <a:ln>
-            <a:noFill/>
-          </a:ln>
-          <a:effectLst/>
-        </p:spPr>
-        <p:style>
-          <a:lnRef idx="1">
-            <a:schemeClr val="accent1"/>
-          </a:lnRef>
-          <a:fillRef idx="3">
-            <a:schemeClr val="accent1"/>
-          </a:fillRef>
-          <a:effectRef idx="2">
-            <a:schemeClr val="accent1"/>
-          </a:effectRef>
-          <a:fontRef idx="minor">
-            <a:schemeClr val="lt1"/>
-          </a:fontRef>
-        </p:style>
-        <p:txBody>
-          <a:bodyPr rtlCol="0" anchor="ctr"/>
-          <a:lstStyle/>
-          <a:p>
-            <a:pPr algn="ctr"/>
-          </a:p>
-        </p:txBody>
-      </p:sp>
+        </p:spPr>
+      </p:pic>
       <p:sp>
         <p:nvSpPr>
           <p:cNvPr id="3" name="TextBox 2"/>
@@ -3351,7 +3323,7 @@
           <p:nvPr/>
         </p:nvPicPr>
         <p:blipFill>
-          <a:blip r:embed="rId2"/>
+          <a:blip r:embed="rId3"/>
           <a:stretch>
             <a:fillRect/>
           </a:stretch>
@@ -3384,12 +3356,20 @@
         <p:nvPr/>
       </p:nvGrpSpPr>
       <p:grpSpPr/>
-      <p:sp>
-        <p:nvSpPr>
-          <p:cNvPr id="2" name="Rectangle 1"/>
-          <p:cNvSpPr/>
-          <p:nvPr/>
-        </p:nvSpPr>
+      <p:pic>
+        <p:nvPicPr>
+          <p:cNvPr id="2" name="Picture 1" descr="_deck_bg.png"/>
+          <p:cNvPicPr>
+            <a:picLocks noChangeAspect="1"/>
+          </p:cNvPicPr>
+          <p:nvPr/>
+        </p:nvPicPr>
+        <p:blipFill>
+          <a:blip r:embed="rId2"/>
+          <a:stretch>
+            <a:fillRect/>
+          </a:stretch>
+        </p:blipFill>
         <p:spPr>
           <a:xfrm>
             <a:off x="0" y="0"/>
@@ -3398,44 +3378,8 @@
           <a:prstGeom prst="rect">
             <a:avLst/>
           </a:prstGeom>
-          <a:gradFill rotWithShape="1">
-            <a:gsLst>
-              <a:gs pos="0">
-                <a:srgbClr val="06120D"/>
-              </a:gs>
-              <a:gs pos="100000">
-                <a:srgbClr val="06120D"/>
-              </a:gs>
-            </a:gsLst>
-            <a:lin scaled="0" ang="16200000"/>
-          </a:gradFill>
-          <a:ln>
-            <a:noFill/>
-          </a:ln>
-          <a:effectLst/>
-        </p:spPr>
-        <p:style>
-          <a:lnRef idx="1">
-            <a:schemeClr val="accent1"/>
-          </a:lnRef>
-          <a:fillRef idx="3">
-            <a:schemeClr val="accent1"/>
-          </a:fillRef>
-          <a:effectRef idx="2">
-            <a:schemeClr val="accent1"/>
-          </a:effectRef>
-          <a:fontRef idx="minor">
-            <a:schemeClr val="lt1"/>
-          </a:fontRef>
-        </p:style>
-        <p:txBody>
-          <a:bodyPr rtlCol="0" anchor="ctr"/>
-          <a:lstStyle/>
-          <a:p>
-            <a:pPr algn="ctr"/>
-          </a:p>
-        </p:txBody>
-      </p:sp>
+        </p:spPr>
+      </p:pic>
       <p:sp>
         <p:nvSpPr>
           <p:cNvPr id="3" name="TextBox 2"/>
@@ -3932,12 +3876,20 @@
         <p:nvPr/>
       </p:nvGrpSpPr>
       <p:grpSpPr/>
-      <p:sp>
-        <p:nvSpPr>
-          <p:cNvPr id="2" name="Rectangle 1"/>
-          <p:cNvSpPr/>
-          <p:nvPr/>
-        </p:nvSpPr>
+      <p:pic>
+        <p:nvPicPr>
+          <p:cNvPr id="2" name="Picture 1" descr="_deck_bg.png"/>
+          <p:cNvPicPr>
+            <a:picLocks noChangeAspect="1"/>
+          </p:cNvPicPr>
+          <p:nvPr/>
+        </p:nvPicPr>
+        <p:blipFill>
+          <a:blip r:embed="rId2"/>
+          <a:stretch>
+            <a:fillRect/>
+          </a:stretch>
+        </p:blipFill>
         <p:spPr>
           <a:xfrm>
             <a:off x="0" y="0"/>
@@ -3946,44 +3898,8 @@
           <a:prstGeom prst="rect">
             <a:avLst/>
           </a:prstGeom>
-          <a:gradFill rotWithShape="1">
-            <a:gsLst>
-              <a:gs pos="0">
-                <a:srgbClr val="0B201A"/>
-              </a:gs>
-              <a:gs pos="100000">
-                <a:srgbClr val="0B201A"/>
-              </a:gs>
-            </a:gsLst>
-            <a:lin scaled="0" ang="16200000"/>
-          </a:gradFill>
-          <a:ln>
-            <a:noFill/>
-          </a:ln>
-          <a:effectLst/>
-        </p:spPr>
-        <p:style>
-          <a:lnRef idx="1">
-            <a:schemeClr val="accent1"/>
-          </a:lnRef>
-          <a:fillRef idx="3">
-            <a:schemeClr val="accent1"/>
-          </a:fillRef>
-          <a:effectRef idx="2">
-            <a:schemeClr val="accent1"/>
-          </a:effectRef>
-          <a:fontRef idx="minor">
-            <a:schemeClr val="lt1"/>
-          </a:fontRef>
-        </p:style>
-        <p:txBody>
-          <a:bodyPr rtlCol="0" anchor="ctr"/>
-          <a:lstStyle/>
-          <a:p>
-            <a:pPr algn="ctr"/>
-          </a:p>
-        </p:txBody>
-      </p:sp>
+        </p:spPr>
+      </p:pic>
       <p:sp>
         <p:nvSpPr>
           <p:cNvPr id="3" name="Oval 2"/>
@@ -4503,12 +4419,20 @@
         <p:nvPr/>
       </p:nvGrpSpPr>
       <p:grpSpPr/>
-      <p:sp>
-        <p:nvSpPr>
-          <p:cNvPr id="2" name="Rectangle 1"/>
-          <p:cNvSpPr/>
-          <p:nvPr/>
-        </p:nvSpPr>
+      <p:pic>
+        <p:nvPicPr>
+          <p:cNvPr id="2" name="Picture 1" descr="_deck_bg.png"/>
+          <p:cNvPicPr>
+            <a:picLocks noChangeAspect="1"/>
+          </p:cNvPicPr>
+          <p:nvPr/>
+        </p:nvPicPr>
+        <p:blipFill>
+          <a:blip r:embed="rId2"/>
+          <a:stretch>
+            <a:fillRect/>
+          </a:stretch>
+        </p:blipFill>
         <p:spPr>
           <a:xfrm>
             <a:off x="0" y="0"/>
@@ -4517,44 +4441,8 @@
           <a:prstGeom prst="rect">
             <a:avLst/>
           </a:prstGeom>
-          <a:gradFill rotWithShape="1">
-            <a:gsLst>
-              <a:gs pos="0">
-                <a:srgbClr val="06120D"/>
-              </a:gs>
-              <a:gs pos="100000">
-                <a:srgbClr val="06120D"/>
-              </a:gs>
-            </a:gsLst>
-            <a:lin scaled="0" ang="16200000"/>
-          </a:gradFill>
-          <a:ln>
-            <a:noFill/>
-          </a:ln>
-          <a:effectLst/>
-        </p:spPr>
-        <p:style>
-          <a:lnRef idx="1">
-            <a:schemeClr val="accent1"/>
-          </a:lnRef>
-          <a:fillRef idx="3">
-            <a:schemeClr val="accent1"/>
-          </a:fillRef>
-          <a:effectRef idx="2">
-            <a:schemeClr val="accent1"/>
-          </a:effectRef>
-          <a:fontRef idx="minor">
-            <a:schemeClr val="lt1"/>
-          </a:fontRef>
-        </p:style>
-        <p:txBody>
-          <a:bodyPr rtlCol="0" anchor="ctr"/>
-          <a:lstStyle/>
-          <a:p>
-            <a:pPr algn="ctr"/>
-          </a:p>
-        </p:txBody>
-      </p:sp>
+        </p:spPr>
+      </p:pic>
       <p:sp>
         <p:nvSpPr>
           <p:cNvPr id="3" name="TextBox 2"/>
@@ -5062,12 +4950,20 @@
         <p:nvPr/>
       </p:nvGrpSpPr>
       <p:grpSpPr/>
-      <p:sp>
-        <p:nvSpPr>
-          <p:cNvPr id="2" name="Rectangle 1"/>
-          <p:cNvSpPr/>
-          <p:nvPr/>
-        </p:nvSpPr>
+      <p:pic>
+        <p:nvPicPr>
+          <p:cNvPr id="2" name="Picture 1" descr="Values (Desktop Wallpaper).jpg"/>
+          <p:cNvPicPr>
+            <a:picLocks noChangeAspect="1"/>
+          </p:cNvPicPr>
+          <p:nvPr/>
+        </p:nvPicPr>
+        <p:blipFill>
+          <a:blip r:embed="rId2"/>
+          <a:stretch>
+            <a:fillRect/>
+          </a:stretch>
+        </p:blipFill>
         <p:spPr>
           <a:xfrm>
             <a:off x="0" y="0"/>
@@ -5076,682 +4972,8 @@
           <a:prstGeom prst="rect">
             <a:avLst/>
           </a:prstGeom>
-          <a:gradFill rotWithShape="1">
-            <a:gsLst>
-              <a:gs pos="0">
-                <a:srgbClr val="06120D"/>
-              </a:gs>
-              <a:gs pos="100000">
-                <a:srgbClr val="06120D"/>
-              </a:gs>
-            </a:gsLst>
-            <a:lin scaled="0" ang="16200000"/>
-          </a:gradFill>
-          <a:ln>
-            <a:noFill/>
-          </a:ln>
-          <a:effectLst/>
-        </p:spPr>
-        <p:style>
-          <a:lnRef idx="1">
-            <a:schemeClr val="accent1"/>
-          </a:lnRef>
-          <a:fillRef idx="3">
-            <a:schemeClr val="accent1"/>
-          </a:fillRef>
-          <a:effectRef idx="2">
-            <a:schemeClr val="accent1"/>
-          </a:effectRef>
-          <a:fontRef idx="minor">
-            <a:schemeClr val="lt1"/>
-          </a:fontRef>
-        </p:style>
-        <p:txBody>
-          <a:bodyPr rtlCol="0" anchor="ctr"/>
-          <a:lstStyle/>
-          <a:p>
-            <a:pPr algn="ctr"/>
-          </a:p>
-        </p:txBody>
-      </p:sp>
-      <p:sp>
-        <p:nvSpPr>
-          <p:cNvPr id="3" name="TextBox 2"/>
-          <p:cNvSpPr txBox="1"/>
-          <p:nvPr/>
-        </p:nvSpPr>
-        <p:spPr>
-          <a:xfrm>
-            <a:off x="868680" y="777240"/>
-            <a:ext cx="7315200" cy="457200"/>
-          </a:xfrm>
-          <a:prstGeom prst="rect">
-            <a:avLst/>
-          </a:prstGeom>
-          <a:noFill/>
-        </p:spPr>
-        <p:txBody>
-          <a:bodyPr wrap="square" anchor="t" lIns="0" rIns="0" tIns="0" bIns="0">
-            <a:spAutoFit/>
-          </a:bodyPr>
-          <a:lstStyle/>
-          <a:p>
-            <a:pPr algn="l">
-              <a:lnSpc>
-                <a:spcPct val="105000"/>
-              </a:lnSpc>
-            </a:pPr>
-            <a:r>
-              <a:rPr sz="1500" b="1" i="0" spc="400">
-                <a:solidFill>
-                  <a:srgbClr val="C9A45C"/>
-                </a:solidFill>
-                <a:latin typeface="Arial"/>
-              </a:rPr>
-              <a:t>OUR VALUES</a:t>
-            </a:r>
-          </a:p>
-        </p:txBody>
-      </p:sp>
-      <p:sp>
-        <p:nvSpPr>
-          <p:cNvPr id="4" name="TextBox 3"/>
-          <p:cNvSpPr txBox="1"/>
-          <p:nvPr/>
-        </p:nvSpPr>
-        <p:spPr>
-          <a:xfrm>
-            <a:off x="868680" y="1234440"/>
-            <a:ext cx="8229600" cy="1005840"/>
-          </a:xfrm>
-          <a:prstGeom prst="rect">
-            <a:avLst/>
-          </a:prstGeom>
-          <a:noFill/>
-        </p:spPr>
-        <p:txBody>
-          <a:bodyPr wrap="square" anchor="t" lIns="0" rIns="0" tIns="0" bIns="0">
-            <a:spAutoFit/>
-          </a:bodyPr>
-          <a:lstStyle/>
-          <a:p>
-            <a:pPr algn="l">
-              <a:lnSpc>
-                <a:spcPct val="105000"/>
-              </a:lnSpc>
-            </a:pPr>
-            <a:r>
-              <a:rPr sz="4600" b="1" i="0">
-                <a:solidFill>
-                  <a:srgbClr val="F3EFE4"/>
-                </a:solidFill>
-                <a:latin typeface="Georgia"/>
-              </a:rPr>
-              <a:t>What we stand for</a:t>
-            </a:r>
-          </a:p>
-        </p:txBody>
-      </p:sp>
-      <p:sp>
-        <p:nvSpPr>
-          <p:cNvPr id="5" name="Rounded Rectangle 4"/>
-          <p:cNvSpPr/>
-          <p:nvPr/>
-        </p:nvSpPr>
-        <p:spPr>
-          <a:xfrm>
-            <a:off x="868680" y="2514600"/>
-            <a:ext cx="4983480" cy="1691640"/>
-          </a:xfrm>
-          <a:prstGeom prst="roundRect">
-            <a:avLst>
-              <a:gd name="adj" fmla="val 8000"/>
-            </a:avLst>
-          </a:prstGeom>
-          <a:solidFill>
-            <a:srgbClr val="1C5C47"/>
-          </a:solidFill>
-          <a:ln w="12700">
-            <a:solidFill>
-              <a:srgbClr val="C9A45C"/>
-            </a:solidFill>
-          </a:ln>
-          <a:effectLst/>
-        </p:spPr>
-        <p:style>
-          <a:lnRef idx="1">
-            <a:schemeClr val="accent1"/>
-          </a:lnRef>
-          <a:fillRef idx="3">
-            <a:schemeClr val="accent1"/>
-          </a:fillRef>
-          <a:effectRef idx="2">
-            <a:schemeClr val="accent1"/>
-          </a:effectRef>
-          <a:fontRef idx="minor">
-            <a:schemeClr val="lt1"/>
-          </a:fontRef>
-        </p:style>
-        <p:txBody>
-          <a:bodyPr rtlCol="0" anchor="ctr"/>
-          <a:lstStyle/>
-          <a:p>
-            <a:pPr algn="ctr"/>
-          </a:p>
-        </p:txBody>
-      </p:sp>
-      <p:sp>
-        <p:nvSpPr>
-          <p:cNvPr id="6" name="Oval 5"/>
-          <p:cNvSpPr/>
-          <p:nvPr/>
-        </p:nvSpPr>
-        <p:spPr>
-          <a:xfrm>
-            <a:off x="1188720" y="2990088"/>
-            <a:ext cx="731520" cy="731520"/>
-          </a:xfrm>
-          <a:prstGeom prst="ellipse">
-            <a:avLst/>
-          </a:prstGeom>
-          <a:solidFill>
-            <a:srgbClr val="C9A45C"/>
-          </a:solidFill>
-          <a:ln>
-            <a:noFill/>
-          </a:ln>
-          <a:effectLst/>
-        </p:spPr>
-        <p:style>
-          <a:lnRef idx="1">
-            <a:schemeClr val="accent1"/>
-          </a:lnRef>
-          <a:fillRef idx="3">
-            <a:schemeClr val="accent1"/>
-          </a:fillRef>
-          <a:effectRef idx="2">
-            <a:schemeClr val="accent1"/>
-          </a:effectRef>
-          <a:fontRef idx="minor">
-            <a:schemeClr val="lt1"/>
-          </a:fontRef>
-        </p:style>
-        <p:txBody>
-          <a:bodyPr rtlCol="0" anchor="ctr" lIns="0" rIns="0" tIns="0" bIns="0" wrap="none"/>
-          <a:lstStyle/>
-          <a:p>
-            <a:pPr algn="ctr"/>
-            <a:r>
-              <a:rPr sz="2200" b="1">
-                <a:solidFill>
-                  <a:srgbClr val="06120D"/>
-                </a:solidFill>
-                <a:latin typeface="Arial"/>
-              </a:rPr>
-              <a:t>◆</a:t>
-            </a:r>
-          </a:p>
-        </p:txBody>
-      </p:sp>
-      <p:sp>
-        <p:nvSpPr>
-          <p:cNvPr id="7" name="TextBox 6"/>
-          <p:cNvSpPr txBox="1"/>
-          <p:nvPr/>
-        </p:nvSpPr>
-        <p:spPr>
-          <a:xfrm>
-            <a:off x="2194560" y="2514600"/>
-            <a:ext cx="3429000" cy="1691640"/>
-          </a:xfrm>
-          <a:prstGeom prst="rect">
-            <a:avLst/>
-          </a:prstGeom>
-          <a:noFill/>
-        </p:spPr>
-        <p:txBody>
-          <a:bodyPr wrap="square" anchor="ctr" lIns="0" rIns="0" tIns="0" bIns="0">
-            <a:spAutoFit/>
-          </a:bodyPr>
-          <a:lstStyle/>
-          <a:p>
-            <a:pPr algn="l">
-              <a:lnSpc>
-                <a:spcPct val="105000"/>
-              </a:lnSpc>
-            </a:pPr>
-            <a:r>
-              <a:rPr sz="2400" b="1" i="0">
-                <a:solidFill>
-                  <a:srgbClr val="F3EFE4"/>
-                </a:solidFill>
-                <a:latin typeface="Georgia"/>
-              </a:rPr>
-              <a:t>Kind to our environment</a:t>
-            </a:r>
-          </a:p>
-        </p:txBody>
-      </p:sp>
-      <p:sp>
-        <p:nvSpPr>
-          <p:cNvPr id="8" name="Rounded Rectangle 7"/>
-          <p:cNvSpPr/>
-          <p:nvPr/>
-        </p:nvSpPr>
-        <p:spPr>
-          <a:xfrm>
-            <a:off x="6263640" y="2514600"/>
-            <a:ext cx="4983480" cy="1691640"/>
-          </a:xfrm>
-          <a:prstGeom prst="roundRect">
-            <a:avLst>
-              <a:gd name="adj" fmla="val 8000"/>
-            </a:avLst>
-          </a:prstGeom>
-          <a:solidFill>
-            <a:srgbClr val="1C5C47"/>
-          </a:solidFill>
-          <a:ln w="12700">
-            <a:solidFill>
-              <a:srgbClr val="C9A45C"/>
-            </a:solidFill>
-          </a:ln>
-          <a:effectLst/>
-        </p:spPr>
-        <p:style>
-          <a:lnRef idx="1">
-            <a:schemeClr val="accent1"/>
-          </a:lnRef>
-          <a:fillRef idx="3">
-            <a:schemeClr val="accent1"/>
-          </a:fillRef>
-          <a:effectRef idx="2">
-            <a:schemeClr val="accent1"/>
-          </a:effectRef>
-          <a:fontRef idx="minor">
-            <a:schemeClr val="lt1"/>
-          </a:fontRef>
-        </p:style>
-        <p:txBody>
-          <a:bodyPr rtlCol="0" anchor="ctr"/>
-          <a:lstStyle/>
-          <a:p>
-            <a:pPr algn="ctr"/>
-          </a:p>
-        </p:txBody>
-      </p:sp>
-      <p:sp>
-        <p:nvSpPr>
-          <p:cNvPr id="9" name="Oval 8"/>
-          <p:cNvSpPr/>
-          <p:nvPr/>
-        </p:nvSpPr>
-        <p:spPr>
-          <a:xfrm>
-            <a:off x="6583680" y="2990088"/>
-            <a:ext cx="731520" cy="731520"/>
-          </a:xfrm>
-          <a:prstGeom prst="ellipse">
-            <a:avLst/>
-          </a:prstGeom>
-          <a:solidFill>
-            <a:srgbClr val="C9A45C"/>
-          </a:solidFill>
-          <a:ln>
-            <a:noFill/>
-          </a:ln>
-          <a:effectLst/>
-        </p:spPr>
-        <p:style>
-          <a:lnRef idx="1">
-            <a:schemeClr val="accent1"/>
-          </a:lnRef>
-          <a:fillRef idx="3">
-            <a:schemeClr val="accent1"/>
-          </a:fillRef>
-          <a:effectRef idx="2">
-            <a:schemeClr val="accent1"/>
-          </a:effectRef>
-          <a:fontRef idx="minor">
-            <a:schemeClr val="lt1"/>
-          </a:fontRef>
-        </p:style>
-        <p:txBody>
-          <a:bodyPr rtlCol="0" anchor="ctr" lIns="0" rIns="0" tIns="0" bIns="0" wrap="none"/>
-          <a:lstStyle/>
-          <a:p>
-            <a:pPr algn="ctr"/>
-            <a:r>
-              <a:rPr sz="2200" b="1">
-                <a:solidFill>
-                  <a:srgbClr val="06120D"/>
-                </a:solidFill>
-                <a:latin typeface="Arial"/>
-              </a:rPr>
-              <a:t>◆</a:t>
-            </a:r>
-          </a:p>
-        </p:txBody>
-      </p:sp>
-      <p:sp>
-        <p:nvSpPr>
-          <p:cNvPr id="10" name="TextBox 9"/>
-          <p:cNvSpPr txBox="1"/>
-          <p:nvPr/>
-        </p:nvSpPr>
-        <p:spPr>
-          <a:xfrm>
-            <a:off x="7589520" y="2514600"/>
-            <a:ext cx="3429000" cy="1691640"/>
-          </a:xfrm>
-          <a:prstGeom prst="rect">
-            <a:avLst/>
-          </a:prstGeom>
-          <a:noFill/>
-        </p:spPr>
-        <p:txBody>
-          <a:bodyPr wrap="square" anchor="ctr" lIns="0" rIns="0" tIns="0" bIns="0">
-            <a:spAutoFit/>
-          </a:bodyPr>
-          <a:lstStyle/>
-          <a:p>
-            <a:pPr algn="l">
-              <a:lnSpc>
-                <a:spcPct val="105000"/>
-              </a:lnSpc>
-            </a:pPr>
-            <a:r>
-              <a:rPr sz="2400" b="1" i="0">
-                <a:solidFill>
-                  <a:srgbClr val="F3EFE4"/>
-                </a:solidFill>
-                <a:latin typeface="Georgia"/>
-              </a:rPr>
-              <a:t>Delighted customers</a:t>
-            </a:r>
-          </a:p>
-        </p:txBody>
-      </p:sp>
-      <p:sp>
-        <p:nvSpPr>
-          <p:cNvPr id="11" name="Rounded Rectangle 10"/>
-          <p:cNvSpPr/>
-          <p:nvPr/>
-        </p:nvSpPr>
-        <p:spPr>
-          <a:xfrm>
-            <a:off x="868680" y="4617720"/>
-            <a:ext cx="4983480" cy="1691640"/>
-          </a:xfrm>
-          <a:prstGeom prst="roundRect">
-            <a:avLst>
-              <a:gd name="adj" fmla="val 8000"/>
-            </a:avLst>
-          </a:prstGeom>
-          <a:solidFill>
-            <a:srgbClr val="1C5C47"/>
-          </a:solidFill>
-          <a:ln w="12700">
-            <a:solidFill>
-              <a:srgbClr val="C9A45C"/>
-            </a:solidFill>
-          </a:ln>
-          <a:effectLst/>
-        </p:spPr>
-        <p:style>
-          <a:lnRef idx="1">
-            <a:schemeClr val="accent1"/>
-          </a:lnRef>
-          <a:fillRef idx="3">
-            <a:schemeClr val="accent1"/>
-          </a:fillRef>
-          <a:effectRef idx="2">
-            <a:schemeClr val="accent1"/>
-          </a:effectRef>
-          <a:fontRef idx="minor">
-            <a:schemeClr val="lt1"/>
-          </a:fontRef>
-        </p:style>
-        <p:txBody>
-          <a:bodyPr rtlCol="0" anchor="ctr"/>
-          <a:lstStyle/>
-          <a:p>
-            <a:pPr algn="ctr"/>
-          </a:p>
-        </p:txBody>
-      </p:sp>
-      <p:sp>
-        <p:nvSpPr>
-          <p:cNvPr id="12" name="Oval 11"/>
-          <p:cNvSpPr/>
-          <p:nvPr/>
-        </p:nvSpPr>
-        <p:spPr>
-          <a:xfrm>
-            <a:off x="1188720" y="5093208"/>
-            <a:ext cx="731520" cy="731520"/>
-          </a:xfrm>
-          <a:prstGeom prst="ellipse">
-            <a:avLst/>
-          </a:prstGeom>
-          <a:solidFill>
-            <a:srgbClr val="C9A45C"/>
-          </a:solidFill>
-          <a:ln>
-            <a:noFill/>
-          </a:ln>
-          <a:effectLst/>
-        </p:spPr>
-        <p:style>
-          <a:lnRef idx="1">
-            <a:schemeClr val="accent1"/>
-          </a:lnRef>
-          <a:fillRef idx="3">
-            <a:schemeClr val="accent1"/>
-          </a:fillRef>
-          <a:effectRef idx="2">
-            <a:schemeClr val="accent1"/>
-          </a:effectRef>
-          <a:fontRef idx="minor">
-            <a:schemeClr val="lt1"/>
-          </a:fontRef>
-        </p:style>
-        <p:txBody>
-          <a:bodyPr rtlCol="0" anchor="ctr" lIns="0" rIns="0" tIns="0" bIns="0" wrap="none"/>
-          <a:lstStyle/>
-          <a:p>
-            <a:pPr algn="ctr"/>
-            <a:r>
-              <a:rPr sz="2200" b="1">
-                <a:solidFill>
-                  <a:srgbClr val="06120D"/>
-                </a:solidFill>
-                <a:latin typeface="Arial"/>
-              </a:rPr>
-              <a:t>◆</a:t>
-            </a:r>
-          </a:p>
-        </p:txBody>
-      </p:sp>
-      <p:sp>
-        <p:nvSpPr>
-          <p:cNvPr id="13" name="TextBox 12"/>
-          <p:cNvSpPr txBox="1"/>
-          <p:nvPr/>
-        </p:nvSpPr>
-        <p:spPr>
-          <a:xfrm>
-            <a:off x="2194560" y="4617720"/>
-            <a:ext cx="3429000" cy="1691640"/>
-          </a:xfrm>
-          <a:prstGeom prst="rect">
-            <a:avLst/>
-          </a:prstGeom>
-          <a:noFill/>
-        </p:spPr>
-        <p:txBody>
-          <a:bodyPr wrap="square" anchor="ctr" lIns="0" rIns="0" tIns="0" bIns="0">
-            <a:spAutoFit/>
-          </a:bodyPr>
-          <a:lstStyle/>
-          <a:p>
-            <a:pPr algn="l">
-              <a:lnSpc>
-                <a:spcPct val="105000"/>
-              </a:lnSpc>
-            </a:pPr>
-            <a:r>
-              <a:rPr sz="2400" b="1" i="0">
-                <a:solidFill>
-                  <a:srgbClr val="F3EFE4"/>
-                </a:solidFill>
-                <a:latin typeface="Georgia"/>
-              </a:rPr>
-              <a:t>Honest British craftsmanship</a:t>
-            </a:r>
-          </a:p>
-        </p:txBody>
-      </p:sp>
-      <p:sp>
-        <p:nvSpPr>
-          <p:cNvPr id="14" name="Rounded Rectangle 13"/>
-          <p:cNvSpPr/>
-          <p:nvPr/>
-        </p:nvSpPr>
-        <p:spPr>
-          <a:xfrm>
-            <a:off x="6263640" y="4617720"/>
-            <a:ext cx="4983480" cy="1691640"/>
-          </a:xfrm>
-          <a:prstGeom prst="roundRect">
-            <a:avLst>
-              <a:gd name="adj" fmla="val 8000"/>
-            </a:avLst>
-          </a:prstGeom>
-          <a:solidFill>
-            <a:srgbClr val="1C5C47"/>
-          </a:solidFill>
-          <a:ln w="12700">
-            <a:solidFill>
-              <a:srgbClr val="C9A45C"/>
-            </a:solidFill>
-          </a:ln>
-          <a:effectLst/>
-        </p:spPr>
-        <p:style>
-          <a:lnRef idx="1">
-            <a:schemeClr val="accent1"/>
-          </a:lnRef>
-          <a:fillRef idx="3">
-            <a:schemeClr val="accent1"/>
-          </a:fillRef>
-          <a:effectRef idx="2">
-            <a:schemeClr val="accent1"/>
-          </a:effectRef>
-          <a:fontRef idx="minor">
-            <a:schemeClr val="lt1"/>
-          </a:fontRef>
-        </p:style>
-        <p:txBody>
-          <a:bodyPr rtlCol="0" anchor="ctr"/>
-          <a:lstStyle/>
-          <a:p>
-            <a:pPr algn="ctr"/>
-          </a:p>
-        </p:txBody>
-      </p:sp>
-      <p:sp>
-        <p:nvSpPr>
-          <p:cNvPr id="15" name="Oval 14"/>
-          <p:cNvSpPr/>
-          <p:nvPr/>
-        </p:nvSpPr>
-        <p:spPr>
-          <a:xfrm>
-            <a:off x="6583680" y="5093208"/>
-            <a:ext cx="731520" cy="731520"/>
-          </a:xfrm>
-          <a:prstGeom prst="ellipse">
-            <a:avLst/>
-          </a:prstGeom>
-          <a:solidFill>
-            <a:srgbClr val="C9A45C"/>
-          </a:solidFill>
-          <a:ln>
-            <a:noFill/>
-          </a:ln>
-          <a:effectLst/>
-        </p:spPr>
-        <p:style>
-          <a:lnRef idx="1">
-            <a:schemeClr val="accent1"/>
-          </a:lnRef>
-          <a:fillRef idx="3">
-            <a:schemeClr val="accent1"/>
-          </a:fillRef>
-          <a:effectRef idx="2">
-            <a:schemeClr val="accent1"/>
-          </a:effectRef>
-          <a:fontRef idx="minor">
-            <a:schemeClr val="lt1"/>
-          </a:fontRef>
-        </p:style>
-        <p:txBody>
-          <a:bodyPr rtlCol="0" anchor="ctr" lIns="0" rIns="0" tIns="0" bIns="0" wrap="none"/>
-          <a:lstStyle/>
-          <a:p>
-            <a:pPr algn="ctr"/>
-            <a:r>
-              <a:rPr sz="2200" b="1">
-                <a:solidFill>
-                  <a:srgbClr val="06120D"/>
-                </a:solidFill>
-                <a:latin typeface="Arial"/>
-              </a:rPr>
-              <a:t>◆</a:t>
-            </a:r>
-          </a:p>
-        </p:txBody>
-      </p:sp>
-      <p:sp>
-        <p:nvSpPr>
-          <p:cNvPr id="16" name="TextBox 15"/>
-          <p:cNvSpPr txBox="1"/>
-          <p:nvPr/>
-        </p:nvSpPr>
-        <p:spPr>
-          <a:xfrm>
-            <a:off x="7589520" y="4617720"/>
-            <a:ext cx="3429000" cy="1691640"/>
-          </a:xfrm>
-          <a:prstGeom prst="rect">
-            <a:avLst/>
-          </a:prstGeom>
-          <a:noFill/>
-        </p:spPr>
-        <p:txBody>
-          <a:bodyPr wrap="square" anchor="ctr" lIns="0" rIns="0" tIns="0" bIns="0">
-            <a:spAutoFit/>
-          </a:bodyPr>
-          <a:lstStyle/>
-          <a:p>
-            <a:pPr algn="l">
-              <a:lnSpc>
-                <a:spcPct val="105000"/>
-              </a:lnSpc>
-            </a:pPr>
-            <a:r>
-              <a:rPr sz="2400" b="1" i="0">
-                <a:solidFill>
-                  <a:srgbClr val="F3EFE4"/>
-                </a:solidFill>
-                <a:latin typeface="Georgia"/>
-              </a:rPr>
-              <a:t>Happy co-owners</a:t>
-            </a:r>
-          </a:p>
-        </p:txBody>
-      </p:sp>
+        </p:spPr>
+      </p:pic>
     </p:spTree>
   </p:cSld>
   <p:clrMapOvr>
@@ -5770,12 +4992,20 @@
         <p:nvPr/>
       </p:nvGrpSpPr>
       <p:grpSpPr/>
-      <p:sp>
-        <p:nvSpPr>
-          <p:cNvPr id="2" name="Rectangle 1"/>
-          <p:cNvSpPr/>
-          <p:nvPr/>
-        </p:nvSpPr>
+      <p:pic>
+        <p:nvPicPr>
+          <p:cNvPr id="2" name="Picture 1" descr="_deck_bg.png"/>
+          <p:cNvPicPr>
+            <a:picLocks noChangeAspect="1"/>
+          </p:cNvPicPr>
+          <p:nvPr/>
+        </p:nvPicPr>
+        <p:blipFill>
+          <a:blip r:embed="rId2"/>
+          <a:stretch>
+            <a:fillRect/>
+          </a:stretch>
+        </p:blipFill>
         <p:spPr>
           <a:xfrm>
             <a:off x="0" y="0"/>
@@ -5784,44 +5014,8 @@
           <a:prstGeom prst="rect">
             <a:avLst/>
           </a:prstGeom>
-          <a:gradFill rotWithShape="1">
-            <a:gsLst>
-              <a:gs pos="0">
-                <a:srgbClr val="06120D"/>
-              </a:gs>
-              <a:gs pos="100000">
-                <a:srgbClr val="06120D"/>
-              </a:gs>
-            </a:gsLst>
-            <a:lin scaled="0" ang="16200000"/>
-          </a:gradFill>
-          <a:ln>
-            <a:noFill/>
-          </a:ln>
-          <a:effectLst/>
-        </p:spPr>
-        <p:style>
-          <a:lnRef idx="1">
-            <a:schemeClr val="accent1"/>
-          </a:lnRef>
-          <a:fillRef idx="3">
-            <a:schemeClr val="accent1"/>
-          </a:fillRef>
-          <a:effectRef idx="2">
-            <a:schemeClr val="accent1"/>
-          </a:effectRef>
-          <a:fontRef idx="minor">
-            <a:schemeClr val="lt1"/>
-          </a:fontRef>
-        </p:style>
-        <p:txBody>
-          <a:bodyPr rtlCol="0" anchor="ctr"/>
-          <a:lstStyle/>
-          <a:p>
-            <a:pPr algn="ctr"/>
-          </a:p>
-        </p:txBody>
-      </p:sp>
+        </p:spPr>
+      </p:pic>
       <p:sp>
         <p:nvSpPr>
           <p:cNvPr id="3" name="Rectangle 2"/>
@@ -6401,12 +5595,20 @@
         <p:nvPr/>
       </p:nvGrpSpPr>
       <p:grpSpPr/>
-      <p:sp>
-        <p:nvSpPr>
-          <p:cNvPr id="2" name="Rectangle 1"/>
-          <p:cNvSpPr/>
-          <p:nvPr/>
-        </p:nvSpPr>
+      <p:pic>
+        <p:nvPicPr>
+          <p:cNvPr id="2" name="Picture 1" descr="_deck_bg.png"/>
+          <p:cNvPicPr>
+            <a:picLocks noChangeAspect="1"/>
+          </p:cNvPicPr>
+          <p:nvPr/>
+        </p:nvPicPr>
+        <p:blipFill>
+          <a:blip r:embed="rId2"/>
+          <a:stretch>
+            <a:fillRect/>
+          </a:stretch>
+        </p:blipFill>
         <p:spPr>
           <a:xfrm>
             <a:off x="0" y="0"/>
@@ -6415,44 +5617,8 @@
           <a:prstGeom prst="rect">
             <a:avLst/>
           </a:prstGeom>
-          <a:gradFill rotWithShape="1">
-            <a:gsLst>
-              <a:gs pos="0">
-                <a:srgbClr val="0B201A"/>
-              </a:gs>
-              <a:gs pos="100000">
-                <a:srgbClr val="0B201A"/>
-              </a:gs>
-            </a:gsLst>
-            <a:lin scaled="0" ang="16200000"/>
-          </a:gradFill>
-          <a:ln>
-            <a:noFill/>
-          </a:ln>
-          <a:effectLst/>
-        </p:spPr>
-        <p:style>
-          <a:lnRef idx="1">
-            <a:schemeClr val="accent1"/>
-          </a:lnRef>
-          <a:fillRef idx="3">
-            <a:schemeClr val="accent1"/>
-          </a:fillRef>
-          <a:effectRef idx="2">
-            <a:schemeClr val="accent1"/>
-          </a:effectRef>
-          <a:fontRef idx="minor">
-            <a:schemeClr val="lt1"/>
-          </a:fontRef>
-        </p:style>
-        <p:txBody>
-          <a:bodyPr rtlCol="0" anchor="ctr"/>
-          <a:lstStyle/>
-          <a:p>
-            <a:pPr algn="ctr"/>
-          </a:p>
-        </p:txBody>
-      </p:sp>
+        </p:spPr>
+      </p:pic>
       <p:sp>
         <p:nvSpPr>
           <p:cNvPr id="3" name="TextBox 2"/>
@@ -7125,12 +6291,20 @@
         <p:nvPr/>
       </p:nvGrpSpPr>
       <p:grpSpPr/>
-      <p:sp>
-        <p:nvSpPr>
-          <p:cNvPr id="2" name="Rectangle 1"/>
-          <p:cNvSpPr/>
-          <p:nvPr/>
-        </p:nvSpPr>
+      <p:pic>
+        <p:nvPicPr>
+          <p:cNvPr id="2" name="Picture 1" descr="_deck_bg.png"/>
+          <p:cNvPicPr>
+            <a:picLocks noChangeAspect="1"/>
+          </p:cNvPicPr>
+          <p:nvPr/>
+        </p:nvPicPr>
+        <p:blipFill>
+          <a:blip r:embed="rId2"/>
+          <a:stretch>
+            <a:fillRect/>
+          </a:stretch>
+        </p:blipFill>
         <p:spPr>
           <a:xfrm>
             <a:off x="0" y="0"/>
@@ -7139,44 +6313,8 @@
           <a:prstGeom prst="rect">
             <a:avLst/>
           </a:prstGeom>
-          <a:gradFill rotWithShape="1">
-            <a:gsLst>
-              <a:gs pos="0">
-                <a:srgbClr val="06120D"/>
-              </a:gs>
-              <a:gs pos="100000">
-                <a:srgbClr val="06120D"/>
-              </a:gs>
-            </a:gsLst>
-            <a:lin scaled="0" ang="16200000"/>
-          </a:gradFill>
-          <a:ln>
-            <a:noFill/>
-          </a:ln>
-          <a:effectLst/>
-        </p:spPr>
-        <p:style>
-          <a:lnRef idx="1">
-            <a:schemeClr val="accent1"/>
-          </a:lnRef>
-          <a:fillRef idx="3">
-            <a:schemeClr val="accent1"/>
-          </a:fillRef>
-          <a:effectRef idx="2">
-            <a:schemeClr val="accent1"/>
-          </a:effectRef>
-          <a:fontRef idx="minor">
-            <a:schemeClr val="lt1"/>
-          </a:fontRef>
-        </p:style>
-        <p:txBody>
-          <a:bodyPr rtlCol="0" anchor="ctr"/>
-          <a:lstStyle/>
-          <a:p>
-            <a:pPr algn="ctr"/>
-          </a:p>
-        </p:txBody>
-      </p:sp>
+        </p:spPr>
+      </p:pic>
       <p:sp>
         <p:nvSpPr>
           <p:cNvPr id="3" name="TextBox 2"/>

</xml_diff>

<commit_message>
Restyle starter deck to official brand palette, lighter backgrounds
- Backgrounds rebuilt from brand colours + patterns: light slides use an
  ivory (#fdf3d6) field woven with pattern-02 diamonds (soft tint for
  legibility); cover + birthday use brand Dark Green (#003d22) textured with
  pattern-01. Values slide keeps the brand wallpaper.
- Text colours adapted per background (Dark Green on ivory, ivory on green;
  Bright Green #00a478 accents). Dropped off-brand amber on the safety slide.
- All 8 slides re-rendered and visually QA'd.

Co-Authored-By: Claude Opus 4.8 (1M context) <noreply@anthropic.com>
</commit_message>
<xml_diff>
--- a/starter-deck/board.pptx
+++ b/starter-deck/board.pptx
@@ -3097,7 +3097,7 @@
       <p:grpSpPr/>
       <p:pic>
         <p:nvPicPr>
-          <p:cNvPr id="2" name="Picture 1" descr="_deck_bg.png"/>
+          <p:cNvPr id="2" name="Picture 1" descr="_bg_green.png"/>
           <p:cNvPicPr>
             <a:picLocks noChangeAspect="1"/>
           </p:cNvPicPr>
@@ -3128,7 +3128,7 @@
         <p:spPr>
           <a:xfrm>
             <a:off x="868680" y="1051560"/>
-            <a:ext cx="7315200" cy="457200"/>
+            <a:ext cx="8229600" cy="457200"/>
           </a:xfrm>
           <a:prstGeom prst="rect">
             <a:avLst/>
@@ -3149,7 +3149,7 @@
             <a:r>
               <a:rPr sz="1500" b="1" i="0" spc="400">
                 <a:solidFill>
-                  <a:srgbClr val="C9A45C"/>
+                  <a:srgbClr val="FDF3D6"/>
                 </a:solidFill>
                 <a:latin typeface="Arial"/>
               </a:rPr>
@@ -3188,7 +3188,7 @@
             <a:r>
               <a:rPr sz="5000" b="1" i="0">
                 <a:solidFill>
-                  <a:srgbClr val="F3EFE4"/>
+                  <a:srgbClr val="FDF3D6"/>
                 </a:solidFill>
                 <a:latin typeface="Georgia"/>
               </a:rPr>
@@ -3227,7 +3227,7 @@
             <a:r>
               <a:rPr sz="2200" b="0" i="0">
                 <a:solidFill>
-                  <a:srgbClr val="CFE8DD"/>
+                  <a:srgbClr val="FDF3D6"/>
                 </a:solidFill>
                 <a:latin typeface="Arial"/>
               </a:rPr>
@@ -3266,7 +3266,7 @@
             <a:r>
               <a:rPr sz="1300" b="1" i="0" spc="300">
                 <a:solidFill>
-                  <a:srgbClr val="C9A45C"/>
+                  <a:srgbClr val="00A478"/>
                 </a:solidFill>
                 <a:latin typeface="Arial"/>
               </a:rPr>
@@ -3305,11 +3305,11 @@
             <a:r>
               <a:rPr sz="2400" b="1" i="0">
                 <a:solidFill>
-                  <a:srgbClr val="F3EFE4"/>
+                  <a:srgbClr val="FDF3D6"/>
                 </a:solidFill>
                 <a:latin typeface="Georgia"/>
               </a:rPr>
-              <a:t>07:30 – 17:00</a:t>
+              <a:t>07:30 - 17:00</a:t>
             </a:r>
           </a:p>
         </p:txBody>
@@ -3358,7 +3358,7 @@
       <p:grpSpPr/>
       <p:pic>
         <p:nvPicPr>
-          <p:cNvPr id="2" name="Picture 1" descr="_deck_bg.png"/>
+          <p:cNvPr id="2" name="Picture 1" descr="_bg_light.png"/>
           <p:cNvPicPr>
             <a:picLocks noChangeAspect="1"/>
           </p:cNvPicPr>
@@ -3389,7 +3389,7 @@
         <p:spPr>
           <a:xfrm>
             <a:off x="868680" y="868680"/>
-            <a:ext cx="7315200" cy="457200"/>
+            <a:ext cx="8229600" cy="457200"/>
           </a:xfrm>
           <a:prstGeom prst="rect">
             <a:avLst/>
@@ -3410,7 +3410,7 @@
             <a:r>
               <a:rPr sz="1500" b="1" i="0" spc="400">
                 <a:solidFill>
-                  <a:srgbClr val="C9A45C"/>
+                  <a:srgbClr val="00A478"/>
                 </a:solidFill>
                 <a:latin typeface="Arial"/>
               </a:rPr>
@@ -3449,7 +3449,7 @@
             <a:r>
               <a:rPr sz="4600" b="1" i="0">
                 <a:solidFill>
-                  <a:srgbClr val="F3EFE4"/>
+                  <a:srgbClr val="003D22"/>
                 </a:solidFill>
                 <a:latin typeface="Georgia"/>
               </a:rPr>
@@ -3488,7 +3488,7 @@
             <a:r>
               <a:rPr sz="2000" b="0" i="0">
                 <a:solidFill>
-                  <a:srgbClr val="CFE8DD"/>
+                  <a:srgbClr val="003D22"/>
                 </a:solidFill>
                 <a:latin typeface="Arial"/>
               </a:rPr>
@@ -3514,12 +3514,10 @@
             </a:avLst>
           </a:prstGeom>
           <a:solidFill>
-            <a:srgbClr val="1C5C47"/>
+            <a:srgbClr val="00A478"/>
           </a:solidFill>
-          <a:ln w="12700">
-            <a:solidFill>
-              <a:srgbClr val="C9A45C"/>
-            </a:solidFill>
+          <a:ln>
+            <a:noFill/>
           </a:ln>
           <a:effectLst/>
         </p:spPr>
@@ -3575,7 +3573,7 @@
             <a:r>
               <a:rPr sz="1300" b="1" i="0" spc="300">
                 <a:solidFill>
-                  <a:srgbClr val="ECD6A3"/>
+                  <a:srgbClr val="FDF3D6"/>
                 </a:solidFill>
                 <a:latin typeface="Arial"/>
               </a:rPr>
@@ -3614,7 +3612,7 @@
             <a:r>
               <a:rPr sz="2400" b="1" i="0">
                 <a:solidFill>
-                  <a:srgbClr val="F3EFE4"/>
+                  <a:srgbClr val="FDF3D6"/>
                 </a:solidFill>
                 <a:latin typeface="Georgia"/>
               </a:rPr>
@@ -3654,7 +3652,7 @@
             <a:r>
               <a:rPr sz="2600" b="1" i="0">
                 <a:solidFill>
-                  <a:srgbClr val="C9A45C"/>
+                  <a:srgbClr val="00A478"/>
                 </a:solidFill>
                 <a:latin typeface="Georgia"/>
               </a:rPr>
@@ -3693,7 +3691,7 @@
             <a:r>
               <a:rPr sz="2000" b="0" i="0">
                 <a:solidFill>
-                  <a:srgbClr val="F3EFE4"/>
+                  <a:srgbClr val="003D22"/>
                 </a:solidFill>
                 <a:latin typeface="Arial"/>
               </a:rPr>
@@ -3732,7 +3730,7 @@
             <a:r>
               <a:rPr sz="2600" b="1" i="0">
                 <a:solidFill>
-                  <a:srgbClr val="C9A45C"/>
+                  <a:srgbClr val="00A478"/>
                 </a:solidFill>
                 <a:latin typeface="Georgia"/>
               </a:rPr>
@@ -3771,7 +3769,7 @@
             <a:r>
               <a:rPr sz="2000" b="0" i="0">
                 <a:solidFill>
-                  <a:srgbClr val="F3EFE4"/>
+                  <a:srgbClr val="003D22"/>
                 </a:solidFill>
                 <a:latin typeface="Arial"/>
               </a:rPr>
@@ -3810,7 +3808,7 @@
             <a:r>
               <a:rPr sz="2600" b="1" i="0">
                 <a:solidFill>
-                  <a:srgbClr val="C9A45C"/>
+                  <a:srgbClr val="00A478"/>
                 </a:solidFill>
                 <a:latin typeface="Georgia"/>
               </a:rPr>
@@ -3849,7 +3847,7 @@
             <a:r>
               <a:rPr sz="2000" b="0" i="0">
                 <a:solidFill>
-                  <a:srgbClr val="F3EFE4"/>
+                  <a:srgbClr val="003D22"/>
                 </a:solidFill>
                 <a:latin typeface="Arial"/>
               </a:rPr>
@@ -3878,7 +3876,7 @@
       <p:grpSpPr/>
       <p:pic>
         <p:nvPicPr>
-          <p:cNvPr id="2" name="Picture 1" descr="_deck_bg.png"/>
+          <p:cNvPr id="2" name="Picture 1" descr="_bg_green.png"/>
           <p:cNvPicPr>
             <a:picLocks noChangeAspect="1"/>
           </p:cNvPicPr>
@@ -3915,7 +3913,7 @@
             <a:avLst/>
           </a:prstGeom>
           <a:solidFill>
-            <a:srgbClr val="C9A45C"/>
+            <a:srgbClr val="00A478"/>
           </a:solidFill>
           <a:ln>
             <a:noFill/>
@@ -3959,7 +3957,7 @@
             <a:avLst/>
           </a:prstGeom>
           <a:solidFill>
-            <a:srgbClr val="CFE8DD"/>
+            <a:srgbClr val="FDF3D6"/>
           </a:solidFill>
           <a:ln>
             <a:noFill/>
@@ -4003,7 +4001,7 @@
             <a:avLst/>
           </a:prstGeom>
           <a:solidFill>
-            <a:srgbClr val="ECD6A3"/>
+            <a:srgbClr val="00A478"/>
           </a:solidFill>
           <a:ln>
             <a:noFill/>
@@ -4047,7 +4045,7 @@
             <a:avLst/>
           </a:prstGeom>
           <a:solidFill>
-            <a:srgbClr val="CFE8DD"/>
+            <a:srgbClr val="FDF3D6"/>
           </a:solidFill>
           <a:ln>
             <a:noFill/>
@@ -4091,7 +4089,7 @@
             <a:avLst/>
           </a:prstGeom>
           <a:solidFill>
-            <a:srgbClr val="C9A45C"/>
+            <a:srgbClr val="00A478"/>
           </a:solidFill>
           <a:ln>
             <a:noFill/>
@@ -4129,7 +4127,7 @@
         <p:spPr>
           <a:xfrm>
             <a:off x="868680" y="1371600"/>
-            <a:ext cx="7315200" cy="457200"/>
+            <a:ext cx="8229600" cy="457200"/>
           </a:xfrm>
           <a:prstGeom prst="rect">
             <a:avLst/>
@@ -4150,7 +4148,7 @@
             <a:r>
               <a:rPr sz="1500" b="1" i="0" spc="400">
                 <a:solidFill>
-                  <a:srgbClr val="CFE8DD"/>
+                  <a:srgbClr val="FDF3D6"/>
                 </a:solidFill>
                 <a:latin typeface="Arial"/>
               </a:rPr>
@@ -4189,7 +4187,7 @@
             <a:r>
               <a:rPr sz="5800" b="1" i="0">
                 <a:solidFill>
-                  <a:srgbClr val="F3EFE4"/>
+                  <a:srgbClr val="FDF3D6"/>
                 </a:solidFill>
                 <a:latin typeface="Georgia"/>
               </a:rPr>
@@ -4228,7 +4226,7 @@
             <a:r>
               <a:rPr sz="2200" b="0" i="0">
                 <a:solidFill>
-                  <a:srgbClr val="CFE8DD"/>
+                  <a:srgbClr val="FDF3D6"/>
                 </a:solidFill>
                 <a:latin typeface="Arial"/>
               </a:rPr>
@@ -4267,7 +4265,7 @@
             <a:r>
               <a:rPr sz="1300" b="1" i="0" spc="300">
                 <a:solidFill>
-                  <a:srgbClr val="C9A45C"/>
+                  <a:srgbClr val="00A478"/>
                 </a:solidFill>
                 <a:latin typeface="Arial"/>
               </a:rPr>
@@ -4306,7 +4304,7 @@
             <a:r>
               <a:rPr sz="2400" b="1" i="0">
                 <a:solidFill>
-                  <a:srgbClr val="F3EFE4"/>
+                  <a:srgbClr val="FDF3D6"/>
                 </a:solidFill>
                 <a:latin typeface="Georgia"/>
               </a:rPr>
@@ -4334,7 +4332,7 @@
           <a:noFill/>
           <a:ln w="19050">
             <a:solidFill>
-              <a:srgbClr val="C9A45C"/>
+              <a:srgbClr val="FDF3D6"/>
             </a:solidFill>
             <a:prstDash val="sysDash"/>
           </a:ln>
@@ -4392,7 +4390,7 @@
             <a:r>
               <a:rPr sz="1600" b="0" i="0" spc="200">
                 <a:solidFill>
-                  <a:srgbClr val="BECDC4"/>
+                  <a:srgbClr val="FDF3D6"/>
                 </a:solidFill>
                 <a:latin typeface="Arial"/>
               </a:rPr>
@@ -4421,7 +4419,7 @@
       <p:grpSpPr/>
       <p:pic>
         <p:nvPicPr>
-          <p:cNvPr id="2" name="Picture 1" descr="_deck_bg.png"/>
+          <p:cNvPr id="2" name="Picture 1" descr="_bg_light.png"/>
           <p:cNvPicPr>
             <a:picLocks noChangeAspect="1"/>
           </p:cNvPicPr>
@@ -4452,7 +4450,7 @@
         <p:spPr>
           <a:xfrm>
             <a:off x="868680" y="868680"/>
-            <a:ext cx="7315200" cy="457200"/>
+            <a:ext cx="8229600" cy="457200"/>
           </a:xfrm>
           <a:prstGeom prst="rect">
             <a:avLst/>
@@ -4473,7 +4471,7 @@
             <a:r>
               <a:rPr sz="1500" b="1" i="0" spc="400">
                 <a:solidFill>
-                  <a:srgbClr val="C9A45C"/>
+                  <a:srgbClr val="00A478"/>
                 </a:solidFill>
                 <a:latin typeface="Arial"/>
               </a:rPr>
@@ -4512,7 +4510,7 @@
             <a:r>
               <a:rPr sz="4600" b="1" i="0">
                 <a:solidFill>
-                  <a:srgbClr val="F3EFE4"/>
+                  <a:srgbClr val="003D22"/>
                 </a:solidFill>
                 <a:latin typeface="Georgia"/>
               </a:rPr>
@@ -4551,7 +4549,7 @@
             <a:r>
               <a:rPr sz="2000" b="0" i="0">
                 <a:solidFill>
-                  <a:srgbClr val="CFE8DD"/>
+                  <a:srgbClr val="003D22"/>
                 </a:solidFill>
                 <a:latin typeface="Arial"/>
               </a:rPr>
@@ -4577,7 +4575,7 @@
             </a:avLst>
           </a:prstGeom>
           <a:solidFill>
-            <a:srgbClr val="C9A45C"/>
+            <a:srgbClr val="003D22"/>
           </a:solidFill>
           <a:ln>
             <a:noFill/>
@@ -4636,7 +4634,7 @@
             <a:r>
               <a:rPr sz="2200" b="1" i="0">
                 <a:solidFill>
-                  <a:srgbClr val="06120D"/>
+                  <a:srgbClr val="FDF3D6"/>
                 </a:solidFill>
                 <a:latin typeface="Georgia"/>
               </a:rPr>
@@ -4675,11 +4673,11 @@
             <a:r>
               <a:rPr sz="2200" b="0" i="0">
                 <a:solidFill>
-                  <a:srgbClr val="F3EFE4"/>
+                  <a:srgbClr val="003D22"/>
                 </a:solidFill>
                 <a:latin typeface="Arial"/>
               </a:rPr>
-              <a:t>Co-owners coffee  ·  Kitchen  ·  09:00</a:t>
+              <a:t>Co-owners coffee  -  Kitchen  -  09:00</a:t>
             </a:r>
           </a:p>
         </p:txBody>
@@ -4701,7 +4699,7 @@
             </a:avLst>
           </a:prstGeom>
           <a:solidFill>
-            <a:srgbClr val="C9A45C"/>
+            <a:srgbClr val="003D22"/>
           </a:solidFill>
           <a:ln>
             <a:noFill/>
@@ -4760,7 +4758,7 @@
             <a:r>
               <a:rPr sz="2200" b="1" i="0">
                 <a:solidFill>
-                  <a:srgbClr val="06120D"/>
+                  <a:srgbClr val="FDF3D6"/>
                 </a:solidFill>
                 <a:latin typeface="Georgia"/>
               </a:rPr>
@@ -4799,11 +4797,11 @@
             <a:r>
               <a:rPr sz="2200" b="0" i="0">
                 <a:solidFill>
-                  <a:srgbClr val="F3EFE4"/>
+                  <a:srgbClr val="003D22"/>
                 </a:solidFill>
                 <a:latin typeface="Arial"/>
               </a:rPr>
-              <a:t>Fire drill  ·  whole building  ·  11:30</a:t>
+              <a:t>Fire drill  -  whole building  -  11:30</a:t>
             </a:r>
           </a:p>
         </p:txBody>
@@ -4825,7 +4823,7 @@
             </a:avLst>
           </a:prstGeom>
           <a:solidFill>
-            <a:srgbClr val="C9A45C"/>
+            <a:srgbClr val="003D22"/>
           </a:solidFill>
           <a:ln>
             <a:noFill/>
@@ -4884,7 +4882,7 @@
             <a:r>
               <a:rPr sz="2200" b="1" i="0">
                 <a:solidFill>
-                  <a:srgbClr val="06120D"/>
+                  <a:srgbClr val="FDF3D6"/>
                 </a:solidFill>
                 <a:latin typeface="Georgia"/>
               </a:rPr>
@@ -4923,11 +4921,11 @@
             <a:r>
               <a:rPr sz="2200" b="0" i="0">
                 <a:solidFill>
-                  <a:srgbClr val="F3EFE4"/>
+                  <a:srgbClr val="003D22"/>
                 </a:solidFill>
                 <a:latin typeface="Arial"/>
               </a:rPr>
-              <a:t>Aurora press preview  ·  Showroom  ·  10:00</a:t>
+              <a:t>Aurora press preview  -  Showroom  -  10:00</a:t>
             </a:r>
           </a:p>
         </p:txBody>
@@ -4994,7 +4992,7 @@
       <p:grpSpPr/>
       <p:pic>
         <p:nvPicPr>
-          <p:cNvPr id="2" name="Picture 1" descr="_deck_bg.png"/>
+          <p:cNvPr id="2" name="Picture 1" descr="_bg_light.png"/>
           <p:cNvPicPr>
             <a:picLocks noChangeAspect="1"/>
           </p:cNvPicPr>
@@ -5031,7 +5029,7 @@
             <a:avLst/>
           </a:prstGeom>
           <a:solidFill>
-            <a:srgbClr val="E3A93C"/>
+            <a:srgbClr val="00A478"/>
           </a:solidFill>
           <a:ln>
             <a:noFill/>
@@ -5069,7 +5067,7 @@
         <p:spPr>
           <a:xfrm>
             <a:off x="868680" y="868680"/>
-            <a:ext cx="7315200" cy="457200"/>
+            <a:ext cx="8229600" cy="457200"/>
           </a:xfrm>
           <a:prstGeom prst="rect">
             <a:avLst/>
@@ -5090,7 +5088,7 @@
             <a:r>
               <a:rPr sz="1500" b="1" i="0" spc="400">
                 <a:solidFill>
-                  <a:srgbClr val="F2C66A"/>
+                  <a:srgbClr val="00A478"/>
                 </a:solidFill>
                 <a:latin typeface="Arial"/>
               </a:rPr>
@@ -5129,7 +5127,7 @@
             <a:r>
               <a:rPr sz="4800" b="1" i="0">
                 <a:solidFill>
-                  <a:srgbClr val="F3EFE4"/>
+                  <a:srgbClr val="003D22"/>
                 </a:solidFill>
                 <a:latin typeface="Georgia"/>
               </a:rPr>
@@ -5168,7 +5166,7 @@
             <a:r>
               <a:rPr sz="2000" b="0" i="0">
                 <a:solidFill>
-                  <a:srgbClr val="CFE8DD"/>
+                  <a:srgbClr val="003D22"/>
                 </a:solidFill>
                 <a:latin typeface="Arial"/>
               </a:rPr>
@@ -5193,11 +5191,11 @@
               <a:gd name="adj" fmla="val 10000"/>
             </a:avLst>
           </a:prstGeom>
-          <a:noFill/>
-          <a:ln w="12700">
-            <a:solidFill>
-              <a:srgbClr val="E3A93C"/>
-            </a:solidFill>
+          <a:solidFill>
+            <a:srgbClr val="00A478"/>
+          </a:solidFill>
+          <a:ln>
+            <a:noFill/>
           </a:ln>
           <a:effectLst/>
         </p:spPr>
@@ -5253,7 +5251,7 @@
             <a:r>
               <a:rPr sz="1300" b="1" i="0" spc="300">
                 <a:solidFill>
-                  <a:srgbClr val="F2C66A"/>
+                  <a:srgbClr val="FDF3D6"/>
                 </a:solidFill>
                 <a:latin typeface="Arial"/>
               </a:rPr>
@@ -5292,7 +5290,7 @@
             <a:r>
               <a:rPr sz="2200" b="1" i="0">
                 <a:solidFill>
-                  <a:srgbClr val="F3EFE4"/>
+                  <a:srgbClr val="FDF3D6"/>
                 </a:solidFill>
                 <a:latin typeface="Georgia"/>
               </a:rPr>
@@ -5316,7 +5314,7 @@
             <a:avLst/>
           </a:prstGeom>
           <a:solidFill>
-            <a:srgbClr val="E3A93C"/>
+            <a:srgbClr val="00A478"/>
           </a:solidFill>
           <a:ln>
             <a:noFill/>
@@ -5345,7 +5343,7 @@
             <a:r>
               <a:rPr sz="1400" b="1">
                 <a:solidFill>
-                  <a:srgbClr val="06120D"/>
+                  <a:srgbClr val="FDF3D6"/>
                 </a:solidFill>
                 <a:latin typeface="Arial"/>
               </a:rPr>
@@ -5384,7 +5382,7 @@
             <a:r>
               <a:rPr sz="2000" b="0" i="0">
                 <a:solidFill>
-                  <a:srgbClr val="F3EFE4"/>
+                  <a:srgbClr val="003D22"/>
                 </a:solidFill>
                 <a:latin typeface="Arial"/>
               </a:rPr>
@@ -5408,7 +5406,7 @@
             <a:avLst/>
           </a:prstGeom>
           <a:solidFill>
-            <a:srgbClr val="E3A93C"/>
+            <a:srgbClr val="00A478"/>
           </a:solidFill>
           <a:ln>
             <a:noFill/>
@@ -5437,7 +5435,7 @@
             <a:r>
               <a:rPr sz="1400" b="1">
                 <a:solidFill>
-                  <a:srgbClr val="06120D"/>
+                  <a:srgbClr val="FDF3D6"/>
                 </a:solidFill>
                 <a:latin typeface="Arial"/>
               </a:rPr>
@@ -5476,7 +5474,7 @@
             <a:r>
               <a:rPr sz="2000" b="0" i="0">
                 <a:solidFill>
-                  <a:srgbClr val="F3EFE4"/>
+                  <a:srgbClr val="003D22"/>
                 </a:solidFill>
                 <a:latin typeface="Arial"/>
               </a:rPr>
@@ -5500,7 +5498,7 @@
             <a:avLst/>
           </a:prstGeom>
           <a:solidFill>
-            <a:srgbClr val="E3A93C"/>
+            <a:srgbClr val="00A478"/>
           </a:solidFill>
           <a:ln>
             <a:noFill/>
@@ -5529,7 +5527,7 @@
             <a:r>
               <a:rPr sz="1400" b="1">
                 <a:solidFill>
-                  <a:srgbClr val="06120D"/>
+                  <a:srgbClr val="FDF3D6"/>
                 </a:solidFill>
                 <a:latin typeface="Arial"/>
               </a:rPr>
@@ -5568,7 +5566,7 @@
             <a:r>
               <a:rPr sz="2000" b="0" i="0">
                 <a:solidFill>
-                  <a:srgbClr val="F3EFE4"/>
+                  <a:srgbClr val="003D22"/>
                 </a:solidFill>
                 <a:latin typeface="Arial"/>
               </a:rPr>
@@ -5597,7 +5595,7 @@
       <p:grpSpPr/>
       <p:pic>
         <p:nvPicPr>
-          <p:cNvPr id="2" name="Picture 1" descr="_deck_bg.png"/>
+          <p:cNvPr id="2" name="Picture 1" descr="_bg_light.png"/>
           <p:cNvPicPr>
             <a:picLocks noChangeAspect="1"/>
           </p:cNvPicPr>
@@ -5628,7 +5626,7 @@
         <p:spPr>
           <a:xfrm>
             <a:off x="868680" y="822960"/>
-            <a:ext cx="7315200" cy="457200"/>
+            <a:ext cx="8229600" cy="457200"/>
           </a:xfrm>
           <a:prstGeom prst="rect">
             <a:avLst/>
@@ -5649,7 +5647,7 @@
             <a:r>
               <a:rPr sz="1500" b="1" i="0" spc="400">
                 <a:solidFill>
-                  <a:srgbClr val="C9A45C"/>
+                  <a:srgbClr val="00A478"/>
                 </a:solidFill>
                 <a:latin typeface="Arial"/>
               </a:rPr>
@@ -5688,7 +5686,7 @@
             <a:r>
               <a:rPr sz="4600" b="1" i="0">
                 <a:solidFill>
-                  <a:srgbClr val="F3EFE4"/>
+                  <a:srgbClr val="003D22"/>
                 </a:solidFill>
                 <a:latin typeface="Georgia"/>
               </a:rPr>
@@ -5727,7 +5725,7 @@
             <a:r>
               <a:rPr sz="2000" b="0" i="0">
                 <a:solidFill>
-                  <a:srgbClr val="CFE8DD"/>
+                  <a:srgbClr val="003D22"/>
                 </a:solidFill>
                 <a:latin typeface="Arial"/>
               </a:rPr>
@@ -5753,12 +5751,10 @@
             </a:avLst>
           </a:prstGeom>
           <a:solidFill>
-            <a:srgbClr val="1C5C47"/>
+            <a:srgbClr val="00A478"/>
           </a:solidFill>
-          <a:ln w="12700">
-            <a:solidFill>
-              <a:srgbClr val="C9A45C"/>
-            </a:solidFill>
+          <a:ln>
+            <a:noFill/>
           </a:ln>
           <a:effectLst/>
         </p:spPr>
@@ -5799,7 +5795,7 @@
             <a:avLst/>
           </a:prstGeom>
           <a:solidFill>
-            <a:srgbClr val="C9A45C"/>
+            <a:srgbClr val="003D22"/>
           </a:solidFill>
           <a:ln>
             <a:noFill/>
@@ -5828,7 +5824,7 @@
             <a:r>
               <a:rPr sz="2600" b="1">
                 <a:solidFill>
-                  <a:srgbClr val="06120D"/>
+                  <a:srgbClr val="FDF3D6"/>
                 </a:solidFill>
                 <a:latin typeface="Georgia"/>
               </a:rPr>
@@ -5867,7 +5863,7 @@
             <a:r>
               <a:rPr sz="2000" b="1" i="0">
                 <a:solidFill>
-                  <a:srgbClr val="ECD6A3"/>
+                  <a:srgbClr val="FDF3D6"/>
                 </a:solidFill>
                 <a:latin typeface="Georgia"/>
               </a:rPr>
@@ -5906,7 +5902,7 @@
             <a:r>
               <a:rPr sz="1600" b="0" i="0">
                 <a:solidFill>
-                  <a:srgbClr val="F3EFE4"/>
+                  <a:srgbClr val="FDF3D6"/>
                 </a:solidFill>
                 <a:latin typeface="Arial"/>
               </a:rPr>
@@ -5932,12 +5928,10 @@
             </a:avLst>
           </a:prstGeom>
           <a:solidFill>
-            <a:srgbClr val="1C5C47"/>
+            <a:srgbClr val="00A478"/>
           </a:solidFill>
-          <a:ln w="12700">
-            <a:solidFill>
-              <a:srgbClr val="C9A45C"/>
-            </a:solidFill>
+          <a:ln>
+            <a:noFill/>
           </a:ln>
           <a:effectLst/>
         </p:spPr>
@@ -5978,7 +5972,7 @@
             <a:avLst/>
           </a:prstGeom>
           <a:solidFill>
-            <a:srgbClr val="C9A45C"/>
+            <a:srgbClr val="003D22"/>
           </a:solidFill>
           <a:ln>
             <a:noFill/>
@@ -6007,7 +6001,7 @@
             <a:r>
               <a:rPr sz="2600" b="1">
                 <a:solidFill>
-                  <a:srgbClr val="06120D"/>
+                  <a:srgbClr val="FDF3D6"/>
                 </a:solidFill>
                 <a:latin typeface="Georgia"/>
               </a:rPr>
@@ -6046,7 +6040,7 @@
             <a:r>
               <a:rPr sz="2000" b="1" i="0">
                 <a:solidFill>
-                  <a:srgbClr val="ECD6A3"/>
+                  <a:srgbClr val="FDF3D6"/>
                 </a:solidFill>
                 <a:latin typeface="Georgia"/>
               </a:rPr>
@@ -6085,7 +6079,7 @@
             <a:r>
               <a:rPr sz="1600" b="0" i="0">
                 <a:solidFill>
-                  <a:srgbClr val="F3EFE4"/>
+                  <a:srgbClr val="FDF3D6"/>
                 </a:solidFill>
                 <a:latin typeface="Arial"/>
               </a:rPr>
@@ -6111,12 +6105,10 @@
             </a:avLst>
           </a:prstGeom>
           <a:solidFill>
-            <a:srgbClr val="1C5C47"/>
+            <a:srgbClr val="00A478"/>
           </a:solidFill>
-          <a:ln w="12700">
-            <a:solidFill>
-              <a:srgbClr val="C9A45C"/>
-            </a:solidFill>
+          <a:ln>
+            <a:noFill/>
           </a:ln>
           <a:effectLst/>
         </p:spPr>
@@ -6157,7 +6149,7 @@
             <a:avLst/>
           </a:prstGeom>
           <a:solidFill>
-            <a:srgbClr val="C9A45C"/>
+            <a:srgbClr val="003D22"/>
           </a:solidFill>
           <a:ln>
             <a:noFill/>
@@ -6186,7 +6178,7 @@
             <a:r>
               <a:rPr sz="2600" b="1">
                 <a:solidFill>
-                  <a:srgbClr val="06120D"/>
+                  <a:srgbClr val="FDF3D6"/>
                 </a:solidFill>
                 <a:latin typeface="Georgia"/>
               </a:rPr>
@@ -6225,7 +6217,7 @@
             <a:r>
               <a:rPr sz="2000" b="1" i="0">
                 <a:solidFill>
-                  <a:srgbClr val="ECD6A3"/>
+                  <a:srgbClr val="FDF3D6"/>
                 </a:solidFill>
                 <a:latin typeface="Georgia"/>
               </a:rPr>
@@ -6264,7 +6256,7 @@
             <a:r>
               <a:rPr sz="1600" b="0" i="0">
                 <a:solidFill>
-                  <a:srgbClr val="F3EFE4"/>
+                  <a:srgbClr val="FDF3D6"/>
                 </a:solidFill>
                 <a:latin typeface="Arial"/>
               </a:rPr>
@@ -6293,7 +6285,7 @@
       <p:grpSpPr/>
       <p:pic>
         <p:nvPicPr>
-          <p:cNvPr id="2" name="Picture 1" descr="_deck_bg.png"/>
+          <p:cNvPr id="2" name="Picture 1" descr="_bg_light.png"/>
           <p:cNvPicPr>
             <a:picLocks noChangeAspect="1"/>
           </p:cNvPicPr>
@@ -6324,7 +6316,7 @@
         <p:spPr>
           <a:xfrm>
             <a:off x="868680" y="1097280"/>
-            <a:ext cx="7315200" cy="457200"/>
+            <a:ext cx="8229600" cy="457200"/>
           </a:xfrm>
           <a:prstGeom prst="rect">
             <a:avLst/>
@@ -6345,7 +6337,7 @@
             <a:r>
               <a:rPr sz="1500" b="1" i="0" spc="400">
                 <a:solidFill>
-                  <a:srgbClr val="C9A45C"/>
+                  <a:srgbClr val="00A478"/>
                 </a:solidFill>
                 <a:latin typeface="Arial"/>
               </a:rPr>
@@ -6384,7 +6376,7 @@
             <a:r>
               <a:rPr sz="4800" b="1" i="0">
                 <a:solidFill>
-                  <a:srgbClr val="F3EFE4"/>
+                  <a:srgbClr val="003D22"/>
                 </a:solidFill>
                 <a:latin typeface="Georgia"/>
               </a:rPr>
@@ -6423,7 +6415,7 @@
             <a:r>
               <a:rPr sz="2200" b="0" i="0">
                 <a:solidFill>
-                  <a:srgbClr val="CFE8DD"/>
+                  <a:srgbClr val="003D22"/>
                 </a:solidFill>
                 <a:latin typeface="Arial"/>
               </a:rPr>
@@ -6462,7 +6454,7 @@
             <a:r>
               <a:rPr sz="1300" b="1" i="0" spc="300">
                 <a:solidFill>
-                  <a:srgbClr val="C9A45C"/>
+                  <a:srgbClr val="00A478"/>
                 </a:solidFill>
                 <a:latin typeface="Arial"/>
               </a:rPr>
@@ -6501,7 +6493,7 @@
             <a:r>
               <a:rPr sz="2400" b="1" i="0">
                 <a:solidFill>
-                  <a:srgbClr val="F3EFE4"/>
+                  <a:srgbClr val="003D22"/>
                 </a:solidFill>
                 <a:latin typeface="Georgia"/>
               </a:rPr>
@@ -6527,7 +6519,53 @@
             </a:avLst>
           </a:prstGeom>
           <a:solidFill>
-            <a:srgbClr val="F3EFE4"/>
+            <a:srgbClr val="FFFFFF"/>
+          </a:solidFill>
+          <a:ln w="12700">
+            <a:solidFill>
+              <a:srgbClr val="003D22"/>
+            </a:solidFill>
+          </a:ln>
+          <a:effectLst/>
+        </p:spPr>
+        <p:style>
+          <a:lnRef idx="1">
+            <a:schemeClr val="accent1"/>
+          </a:lnRef>
+          <a:fillRef idx="3">
+            <a:schemeClr val="accent1"/>
+          </a:fillRef>
+          <a:effectRef idx="2">
+            <a:schemeClr val="accent1"/>
+          </a:effectRef>
+          <a:fontRef idx="minor">
+            <a:schemeClr val="lt1"/>
+          </a:fontRef>
+        </p:style>
+        <p:txBody>
+          <a:bodyPr rtlCol="0" anchor="ctr"/>
+          <a:lstStyle/>
+          <a:p>
+            <a:pPr algn="ctr"/>
+          </a:p>
+        </p:txBody>
+      </p:sp>
+      <p:sp>
+        <p:nvSpPr>
+          <p:cNvPr id="9" name="Rectangle 8"/>
+          <p:cNvSpPr/>
+          <p:nvPr/>
+        </p:nvSpPr>
+        <p:spPr>
+          <a:xfrm>
+            <a:off x="10561320" y="2148840"/>
+            <a:ext cx="731520" cy="502920"/>
+          </a:xfrm>
+          <a:prstGeom prst="rect">
+            <a:avLst/>
+          </a:prstGeom>
+          <a:solidFill>
+            <a:srgbClr val="00A478"/>
           </a:solidFill>
           <a:ln>
             <a:noFill/>
@@ -6558,8 +6596,8 @@
       </p:sp>
       <p:sp>
         <p:nvSpPr>
-          <p:cNvPr id="9" name="Rectangle 8"/>
-          <p:cNvSpPr/>
+          <p:cNvPr id="10" name="TextBox 9"/>
+          <p:cNvSpPr txBox="1"/>
           <p:nvPr/>
         </p:nvSpPr>
         <p:spPr>
@@ -6570,8 +6608,47 @@
           <a:prstGeom prst="rect">
             <a:avLst/>
           </a:prstGeom>
+          <a:noFill/>
+        </p:spPr>
+        <p:txBody>
+          <a:bodyPr wrap="square" anchor="ctr" lIns="0" rIns="0" tIns="0" bIns="0">
+            <a:spAutoFit/>
+          </a:bodyPr>
+          <a:lstStyle/>
+          <a:p>
+            <a:pPr algn="ctr">
+              <a:lnSpc>
+                <a:spcPct val="105000"/>
+              </a:lnSpc>
+            </a:pPr>
+            <a:r>
+              <a:rPr sz="1300" b="1" i="0">
+                <a:solidFill>
+                  <a:srgbClr val="FDF3D6"/>
+                </a:solidFill>
+                <a:latin typeface="Arial"/>
+              </a:rPr>
+              <a:t>PDF</a:t>
+            </a:r>
+          </a:p>
+        </p:txBody>
+      </p:sp>
+      <p:sp>
+        <p:nvSpPr>
+          <p:cNvPr id="11" name="Rectangle 10"/>
+          <p:cNvSpPr/>
+          <p:nvPr/>
+        </p:nvSpPr>
+        <p:spPr>
+          <a:xfrm>
+            <a:off x="8869680" y="2971800"/>
+            <a:ext cx="2011680" cy="109728"/>
+          </a:xfrm>
+          <a:prstGeom prst="rect">
+            <a:avLst/>
+          </a:prstGeom>
           <a:solidFill>
-            <a:srgbClr val="C9A45C"/>
+            <a:srgbClr val="C7C9BE"/>
           </a:solidFill>
           <a:ln>
             <a:noFill/>
@@ -6602,59 +6679,20 @@
       </p:sp>
       <p:sp>
         <p:nvSpPr>
-          <p:cNvPr id="10" name="TextBox 9"/>
-          <p:cNvSpPr txBox="1"/>
-          <p:nvPr/>
-        </p:nvSpPr>
-        <p:spPr>
-          <a:xfrm>
-            <a:off x="10561320" y="2148840"/>
-            <a:ext cx="731520" cy="502920"/>
-          </a:xfrm>
-          <a:prstGeom prst="rect">
-            <a:avLst/>
-          </a:prstGeom>
-          <a:noFill/>
-        </p:spPr>
-        <p:txBody>
-          <a:bodyPr wrap="square" anchor="ctr" lIns="0" rIns="0" tIns="0" bIns="0">
-            <a:spAutoFit/>
-          </a:bodyPr>
-          <a:lstStyle/>
-          <a:p>
-            <a:pPr algn="ctr">
-              <a:lnSpc>
-                <a:spcPct val="105000"/>
-              </a:lnSpc>
-            </a:pPr>
-            <a:r>
-              <a:rPr sz="1300" b="1" i="0">
-                <a:solidFill>
-                  <a:srgbClr val="06120D"/>
-                </a:solidFill>
-                <a:latin typeface="Arial"/>
-              </a:rPr>
-              <a:t>PDF</a:t>
-            </a:r>
-          </a:p>
-        </p:txBody>
-      </p:sp>
-      <p:sp>
-        <p:nvSpPr>
-          <p:cNvPr id="11" name="Rectangle 10"/>
+          <p:cNvPr id="12" name="Rectangle 11"/>
           <p:cNvSpPr/>
           <p:nvPr/>
         </p:nvSpPr>
         <p:spPr>
           <a:xfrm>
-            <a:off x="8869680" y="2971800"/>
-            <a:ext cx="2011680" cy="109728"/>
+            <a:off x="8869680" y="3355848"/>
+            <a:ext cx="2194560" cy="109728"/>
           </a:xfrm>
           <a:prstGeom prst="rect">
             <a:avLst/>
           </a:prstGeom>
           <a:solidFill>
-            <a:srgbClr val="C9CBC2"/>
+            <a:srgbClr val="C7C9BE"/>
           </a:solidFill>
           <a:ln>
             <a:noFill/>
@@ -6685,20 +6723,20 @@
       </p:sp>
       <p:sp>
         <p:nvSpPr>
-          <p:cNvPr id="12" name="Rectangle 11"/>
+          <p:cNvPr id="13" name="Rectangle 12"/>
           <p:cNvSpPr/>
           <p:nvPr/>
         </p:nvSpPr>
         <p:spPr>
           <a:xfrm>
-            <a:off x="8869680" y="3355848"/>
-            <a:ext cx="2194560" cy="109728"/>
+            <a:off x="8869680" y="3739896"/>
+            <a:ext cx="1645920" cy="109728"/>
           </a:xfrm>
           <a:prstGeom prst="rect">
             <a:avLst/>
           </a:prstGeom>
           <a:solidFill>
-            <a:srgbClr val="C9CBC2"/>
+            <a:srgbClr val="C7C9BE"/>
           </a:solidFill>
           <a:ln>
             <a:noFill/>
@@ -6729,20 +6767,20 @@
       </p:sp>
       <p:sp>
         <p:nvSpPr>
-          <p:cNvPr id="13" name="Rectangle 12"/>
+          <p:cNvPr id="14" name="Rectangle 13"/>
           <p:cNvSpPr/>
           <p:nvPr/>
         </p:nvSpPr>
         <p:spPr>
           <a:xfrm>
-            <a:off x="8869680" y="3739896"/>
-            <a:ext cx="1645920" cy="109728"/>
+            <a:off x="8869680" y="4123944"/>
+            <a:ext cx="2194560" cy="109728"/>
           </a:xfrm>
           <a:prstGeom prst="rect">
             <a:avLst/>
           </a:prstGeom>
           <a:solidFill>
-            <a:srgbClr val="C9CBC2"/>
+            <a:srgbClr val="C7C9BE"/>
           </a:solidFill>
           <a:ln>
             <a:noFill/>
@@ -6773,20 +6811,20 @@
       </p:sp>
       <p:sp>
         <p:nvSpPr>
-          <p:cNvPr id="14" name="Rectangle 13"/>
+          <p:cNvPr id="15" name="Rectangle 14"/>
           <p:cNvSpPr/>
           <p:nvPr/>
         </p:nvSpPr>
         <p:spPr>
           <a:xfrm>
-            <a:off x="8869680" y="4123944"/>
-            <a:ext cx="2194560" cy="109728"/>
+            <a:off x="8869680" y="4507992"/>
+            <a:ext cx="1920240" cy="109728"/>
           </a:xfrm>
           <a:prstGeom prst="rect">
             <a:avLst/>
           </a:prstGeom>
           <a:solidFill>
-            <a:srgbClr val="C9CBC2"/>
+            <a:srgbClr val="C7C9BE"/>
           </a:solidFill>
           <a:ln>
             <a:noFill/>
@@ -6817,50 +6855,6 @@
       </p:sp>
       <p:sp>
         <p:nvSpPr>
-          <p:cNvPr id="15" name="Rectangle 14"/>
-          <p:cNvSpPr/>
-          <p:nvPr/>
-        </p:nvSpPr>
-        <p:spPr>
-          <a:xfrm>
-            <a:off x="8869680" y="4507992"/>
-            <a:ext cx="1920240" cy="109728"/>
-          </a:xfrm>
-          <a:prstGeom prst="rect">
-            <a:avLst/>
-          </a:prstGeom>
-          <a:solidFill>
-            <a:srgbClr val="C9CBC2"/>
-          </a:solidFill>
-          <a:ln>
-            <a:noFill/>
-          </a:ln>
-          <a:effectLst/>
-        </p:spPr>
-        <p:style>
-          <a:lnRef idx="1">
-            <a:schemeClr val="accent1"/>
-          </a:lnRef>
-          <a:fillRef idx="3">
-            <a:schemeClr val="accent1"/>
-          </a:fillRef>
-          <a:effectRef idx="2">
-            <a:schemeClr val="accent1"/>
-          </a:effectRef>
-          <a:fontRef idx="minor">
-            <a:schemeClr val="lt1"/>
-          </a:fontRef>
-        </p:style>
-        <p:txBody>
-          <a:bodyPr rtlCol="0" anchor="ctr"/>
-          <a:lstStyle/>
-          <a:p>
-            <a:pPr algn="ctr"/>
-          </a:p>
-        </p:txBody>
-      </p:sp>
-      <p:sp>
-        <p:nvSpPr>
           <p:cNvPr id="16" name="Rectangle 15"/>
           <p:cNvSpPr/>
           <p:nvPr/>
@@ -6874,7 +6868,7 @@
             <a:avLst/>
           </a:prstGeom>
           <a:solidFill>
-            <a:srgbClr val="C9CBC2"/>
+            <a:srgbClr val="C7C9BE"/>
           </a:solidFill>
           <a:ln>
             <a:noFill/>

</xml_diff>